<commit_message>
Feat: Complete Week 2 Data Analytics deliverables (SQL, Python EDA, Power BI & Documentation)
</commit_message>
<xml_diff>
--- a/02 - Week 1/Work/FinTrust Digital Bank - Week 1 Data Analytics.pptx
+++ b/02 - Week 1/Work/FinTrust Digital Bank - Week 1 Data Analytics.pptx
@@ -3302,30 +3302,6 @@
       </p:sp>
       <p:pic>
         <p:nvPicPr>
-          <p:cNvPr id="6" name="Picture 5" descr="image.png"/>
-          <p:cNvPicPr>
-            <a:picLocks noChangeAspect="1"/>
-          </p:cNvPicPr>
-          <p:nvPr/>
-        </p:nvPicPr>
-        <p:blipFill>
-          <a:blip r:embed="rId2"/>
-          <a:stretch>
-            <a:fillRect/>
-          </a:stretch>
-        </p:blipFill>
-        <p:spPr>
-          <a:xfrm>
-            <a:off x="609600" y="457200"/>
-            <a:ext cx="2722959" cy="533400"/>
-          </a:xfrm>
-          <a:prstGeom prst="rect">
-            <a:avLst/>
-          </a:prstGeom>
-        </p:spPr>
-      </p:pic>
-      <p:pic>
-        <p:nvPicPr>
           <p:cNvPr id="7" name="Picture 6" descr="image.png"/>
           <p:cNvPicPr>
             <a:picLocks noChangeAspect="1"/>
@@ -3333,7 +3309,7 @@
           <p:nvPr/>
         </p:nvPicPr>
         <p:blipFill>
-          <a:blip r:embed="rId3"/>
+          <a:blip r:embed="rId2"/>
           <a:stretch>
             <a:fillRect/>
           </a:stretch>
@@ -4963,7 +4939,7 @@
       </p:sp>
       <p:pic>
         <p:nvPicPr>
-          <p:cNvPr id="4" name="Picture 3" descr="image.png"/>
+          <p:cNvPr id="5" name="Picture 4" descr="image.png"/>
           <p:cNvPicPr>
             <a:picLocks noChangeAspect="1"/>
           </p:cNvPicPr>
@@ -4977,17 +4953,198 @@
         </p:blipFill>
         <p:spPr>
           <a:xfrm>
-            <a:off x="4164062" y="1343025"/>
-            <a:ext cx="3863875" cy="762000"/>
+            <a:off x="4748212" y="5081587"/>
+            <a:ext cx="171450" cy="171450"/>
           </a:xfrm>
           <a:prstGeom prst="rect">
             <a:avLst/>
           </a:prstGeom>
         </p:spPr>
       </p:pic>
+      <p:sp>
+        <p:nvSpPr>
+          <p:cNvPr id="6" name="TextBox 5"/>
+          <p:cNvSpPr txBox="1"/>
+          <p:nvPr/>
+        </p:nvSpPr>
+        <p:spPr>
+          <a:xfrm>
+            <a:off x="2070496" y="2333625"/>
+            <a:ext cx="8051006" cy="581025"/>
+          </a:xfrm>
+          <a:prstGeom prst="rect">
+            <a:avLst/>
+          </a:prstGeom>
+          <a:noFill/>
+        </p:spPr>
+        <p:txBody>
+          <a:bodyPr wrap="none" lIns="0" tIns="0" rIns="0" bIns="0" anchor="t">
+            <a:spAutoFit/>
+          </a:bodyPr>
+          <a:lstStyle/>
+          <a:p>
+            <a:pPr algn="ctr"/>
+            <a:r>
+              <a:rPr sz="3600" b="1" i="0" u="none">
+                <a:solidFill>
+                  <a:srgbClr val="FFFFFF"/>
+                </a:solidFill>
+                <a:latin typeface="Plus Jakarta Sans"/>
+              </a:rPr>
+              <a:t>Merci pour votre attention !</a:t>
+            </a:r>
+          </a:p>
+        </p:txBody>
+      </p:sp>
+      <p:sp>
+        <p:nvSpPr>
+          <p:cNvPr id="7" name="TextBox 6"/>
+          <p:cNvSpPr txBox="1"/>
+          <p:nvPr/>
+        </p:nvSpPr>
+        <p:spPr>
+          <a:xfrm>
+            <a:off x="2083593" y="3143250"/>
+            <a:ext cx="8024812" cy="238125"/>
+          </a:xfrm>
+          <a:prstGeom prst="rect">
+            <a:avLst/>
+          </a:prstGeom>
+          <a:noFill/>
+        </p:spPr>
+        <p:txBody>
+          <a:bodyPr wrap="none" lIns="0" tIns="0" rIns="0" bIns="0" anchor="t">
+            <a:spAutoFit/>
+          </a:bodyPr>
+          <a:lstStyle/>
+          <a:p>
+            <a:pPr algn="ctr"/>
+            <a:r>
+              <a:rPr sz="1500" b="0" i="0" u="none">
+                <a:solidFill>
+                  <a:srgbClr val="94A3B8"/>
+                </a:solidFill>
+                <a:latin typeface="Plus Jakarta Sans"/>
+              </a:rPr>
+              <a:t>FinTrust Digital Bank — Solution de Business Intelligence &amp; Data Analytics</a:t>
+            </a:r>
+          </a:p>
+        </p:txBody>
+      </p:sp>
+      <p:sp>
+        <p:nvSpPr>
+          <p:cNvPr id="8" name="TextBox 7"/>
+          <p:cNvSpPr txBox="1"/>
+          <p:nvPr/>
+        </p:nvSpPr>
+        <p:spPr>
+          <a:xfrm>
+            <a:off x="3995737" y="4343400"/>
+            <a:ext cx="4200525" cy="285750"/>
+          </a:xfrm>
+          <a:prstGeom prst="rect">
+            <a:avLst/>
+          </a:prstGeom>
+          <a:noFill/>
+        </p:spPr>
+        <p:txBody>
+          <a:bodyPr wrap="none" lIns="0" tIns="0" rIns="0" bIns="0" anchor="t">
+            <a:spAutoFit/>
+          </a:bodyPr>
+          <a:lstStyle/>
+          <a:p>
+            <a:pPr algn="ctr"/>
+            <a:r>
+              <a:rPr sz="1800" b="1" i="0" u="none">
+                <a:solidFill>
+                  <a:srgbClr val="FFFFFF"/>
+                </a:solidFill>
+                <a:latin typeface="Plus Jakarta Sans"/>
+              </a:rPr>
+              <a:t>Mouhamadou Andalla Mbaye</a:t>
+            </a:r>
+          </a:p>
+        </p:txBody>
+      </p:sp>
+      <p:sp>
+        <p:nvSpPr>
+          <p:cNvPr id="9" name="TextBox 8"/>
+          <p:cNvSpPr txBox="1"/>
+          <p:nvPr/>
+        </p:nvSpPr>
+        <p:spPr>
+          <a:xfrm>
+            <a:off x="4327921" y="4705350"/>
+            <a:ext cx="3536156" cy="200025"/>
+          </a:xfrm>
+          <a:prstGeom prst="rect">
+            <a:avLst/>
+          </a:prstGeom>
+          <a:noFill/>
+        </p:spPr>
+        <p:txBody>
+          <a:bodyPr wrap="none" lIns="0" tIns="0" rIns="0" bIns="0" anchor="t">
+            <a:spAutoFit/>
+          </a:bodyPr>
+          <a:lstStyle/>
+          <a:p>
+            <a:pPr algn="ctr"/>
+            <a:r>
+              <a:rPr sz="1200" b="1" i="0" u="none">
+                <a:solidFill>
+                  <a:srgbClr val="38BDF8"/>
+                </a:solidFill>
+                <a:latin typeface="Plus Jakarta Sans"/>
+              </a:rPr>
+              <a:t>Intern Data Analyst — AnalystLab Africa</a:t>
+            </a:r>
+          </a:p>
+        </p:txBody>
+      </p:sp>
+      <p:sp>
+        <p:nvSpPr>
+          <p:cNvPr id="10" name="TextBox 9"/>
+          <p:cNvSpPr txBox="1"/>
+          <p:nvPr/>
+        </p:nvSpPr>
+        <p:spPr>
+          <a:xfrm>
+            <a:off x="4711303" y="5057775"/>
+            <a:ext cx="3036093" cy="219075"/>
+          </a:xfrm>
+          <a:prstGeom prst="rect">
+            <a:avLst/>
+          </a:prstGeom>
+          <a:noFill/>
+        </p:spPr>
+        <p:txBody>
+          <a:bodyPr wrap="none" lIns="0" tIns="0" rIns="0" bIns="0" anchor="t">
+            <a:spAutoFit/>
+          </a:bodyPr>
+          <a:lstStyle/>
+          <a:p>
+            <a:pPr algn="ctr"/>
+            <a:r>
+              <a:rPr sz="1350" b="0" i="0" u="none">
+                <a:solidFill>
+                  <a:srgbClr val="F1F5F9"/>
+                </a:solidFill>
+                <a:latin typeface="Plus Jakarta Sans"/>
+              </a:rPr>
+              <a:t>m.andalla.mbaye@gmail.com</a:t>
+            </a:r>
+          </a:p>
+        </p:txBody>
+      </p:sp>
       <p:pic>
         <p:nvPicPr>
-          <p:cNvPr id="5" name="Picture 4" descr="image.png"/>
+          <p:cNvPr id="12" name="Image 11" descr="Photo de profil de analystlabafrica">
+            <a:extLst>
+              <a:ext uri="{FF2B5EF4-FFF2-40B4-BE49-F238E27FC236}">
+                <a16:creationId xmlns:a16="http://schemas.microsoft.com/office/drawing/2014/main" id="{F3D4557F-EDC6-9079-03EE-88D66900D6E4}"/>
+              </a:ext>
+            </a:extLst>
+          </p:cNvPr>
           <p:cNvPicPr>
             <a:picLocks noChangeAspect="1"/>
           </p:cNvPicPr>
@@ -5001,189 +5158,14 @@
         </p:blipFill>
         <p:spPr>
           <a:xfrm>
-            <a:off x="4748212" y="5081587"/>
-            <a:ext cx="171450" cy="171450"/>
+            <a:off x="5308893" y="521288"/>
+            <a:ext cx="1574212" cy="1574212"/>
           </a:xfrm>
           <a:prstGeom prst="rect">
             <a:avLst/>
           </a:prstGeom>
         </p:spPr>
       </p:pic>
-      <p:sp>
-        <p:nvSpPr>
-          <p:cNvPr id="6" name="TextBox 5"/>
-          <p:cNvSpPr txBox="1"/>
-          <p:nvPr/>
-        </p:nvSpPr>
-        <p:spPr>
-          <a:xfrm>
-            <a:off x="2070496" y="2333625"/>
-            <a:ext cx="8051006" cy="581025"/>
-          </a:xfrm>
-          <a:prstGeom prst="rect">
-            <a:avLst/>
-          </a:prstGeom>
-          <a:noFill/>
-        </p:spPr>
-        <p:txBody>
-          <a:bodyPr wrap="none" lIns="0" tIns="0" rIns="0" bIns="0" anchor="t">
-            <a:spAutoFit/>
-          </a:bodyPr>
-          <a:lstStyle/>
-          <a:p>
-            <a:pPr algn="ctr"/>
-            <a:r>
-              <a:rPr sz="3600" b="1" i="0" u="none">
-                <a:solidFill>
-                  <a:srgbClr val="FFFFFF"/>
-                </a:solidFill>
-                <a:latin typeface="Plus Jakarta Sans"/>
-              </a:rPr>
-              <a:t>Merci pour votre attention !</a:t>
-            </a:r>
-          </a:p>
-        </p:txBody>
-      </p:sp>
-      <p:sp>
-        <p:nvSpPr>
-          <p:cNvPr id="7" name="TextBox 6"/>
-          <p:cNvSpPr txBox="1"/>
-          <p:nvPr/>
-        </p:nvSpPr>
-        <p:spPr>
-          <a:xfrm>
-            <a:off x="2083593" y="3143250"/>
-            <a:ext cx="8024812" cy="238125"/>
-          </a:xfrm>
-          <a:prstGeom prst="rect">
-            <a:avLst/>
-          </a:prstGeom>
-          <a:noFill/>
-        </p:spPr>
-        <p:txBody>
-          <a:bodyPr wrap="none" lIns="0" tIns="0" rIns="0" bIns="0" anchor="t">
-            <a:spAutoFit/>
-          </a:bodyPr>
-          <a:lstStyle/>
-          <a:p>
-            <a:pPr algn="ctr"/>
-            <a:r>
-              <a:rPr sz="1500" b="0" i="0" u="none">
-                <a:solidFill>
-                  <a:srgbClr val="94A3B8"/>
-                </a:solidFill>
-                <a:latin typeface="Plus Jakarta Sans"/>
-              </a:rPr>
-              <a:t>FinTrust Digital Bank — Solution de Business Intelligence &amp; Data Analytics</a:t>
-            </a:r>
-          </a:p>
-        </p:txBody>
-      </p:sp>
-      <p:sp>
-        <p:nvSpPr>
-          <p:cNvPr id="8" name="TextBox 7"/>
-          <p:cNvSpPr txBox="1"/>
-          <p:nvPr/>
-        </p:nvSpPr>
-        <p:spPr>
-          <a:xfrm>
-            <a:off x="3995737" y="4343400"/>
-            <a:ext cx="4200525" cy="285750"/>
-          </a:xfrm>
-          <a:prstGeom prst="rect">
-            <a:avLst/>
-          </a:prstGeom>
-          <a:noFill/>
-        </p:spPr>
-        <p:txBody>
-          <a:bodyPr wrap="none" lIns="0" tIns="0" rIns="0" bIns="0" anchor="t">
-            <a:spAutoFit/>
-          </a:bodyPr>
-          <a:lstStyle/>
-          <a:p>
-            <a:pPr algn="ctr"/>
-            <a:r>
-              <a:rPr sz="1800" b="1" i="0" u="none">
-                <a:solidFill>
-                  <a:srgbClr val="FFFFFF"/>
-                </a:solidFill>
-                <a:latin typeface="Plus Jakarta Sans"/>
-              </a:rPr>
-              <a:t>Mouhamadou Andalla Mbaye</a:t>
-            </a:r>
-          </a:p>
-        </p:txBody>
-      </p:sp>
-      <p:sp>
-        <p:nvSpPr>
-          <p:cNvPr id="9" name="TextBox 8"/>
-          <p:cNvSpPr txBox="1"/>
-          <p:nvPr/>
-        </p:nvSpPr>
-        <p:spPr>
-          <a:xfrm>
-            <a:off x="4327921" y="4705350"/>
-            <a:ext cx="3536156" cy="200025"/>
-          </a:xfrm>
-          <a:prstGeom prst="rect">
-            <a:avLst/>
-          </a:prstGeom>
-          <a:noFill/>
-        </p:spPr>
-        <p:txBody>
-          <a:bodyPr wrap="none" lIns="0" tIns="0" rIns="0" bIns="0" anchor="t">
-            <a:spAutoFit/>
-          </a:bodyPr>
-          <a:lstStyle/>
-          <a:p>
-            <a:pPr algn="ctr"/>
-            <a:r>
-              <a:rPr sz="1200" b="1" i="0" u="none">
-                <a:solidFill>
-                  <a:srgbClr val="38BDF8"/>
-                </a:solidFill>
-                <a:latin typeface="Plus Jakarta Sans"/>
-              </a:rPr>
-              <a:t>Intern Data Analyst — AnalystLab Africa</a:t>
-            </a:r>
-          </a:p>
-        </p:txBody>
-      </p:sp>
-      <p:sp>
-        <p:nvSpPr>
-          <p:cNvPr id="10" name="TextBox 9"/>
-          <p:cNvSpPr txBox="1"/>
-          <p:nvPr/>
-        </p:nvSpPr>
-        <p:spPr>
-          <a:xfrm>
-            <a:off x="4711303" y="5057775"/>
-            <a:ext cx="3036093" cy="219075"/>
-          </a:xfrm>
-          <a:prstGeom prst="rect">
-            <a:avLst/>
-          </a:prstGeom>
-          <a:noFill/>
-        </p:spPr>
-        <p:txBody>
-          <a:bodyPr wrap="none" lIns="0" tIns="0" rIns="0" bIns="0" anchor="t">
-            <a:spAutoFit/>
-          </a:bodyPr>
-          <a:lstStyle/>
-          <a:p>
-            <a:pPr algn="ctr"/>
-            <a:r>
-              <a:rPr sz="1350" b="0" i="0" u="none">
-                <a:solidFill>
-                  <a:srgbClr val="F1F5F9"/>
-                </a:solidFill>
-                <a:latin typeface="Plus Jakarta Sans"/>
-              </a:rPr>
-              <a:t>m.andalla.mbaye@gmail.com</a:t>
-            </a:r>
-          </a:p>
-        </p:txBody>
-      </p:sp>
     </p:spTree>
   </p:cSld>
   <p:clrMapOvr>
@@ -5364,7 +5346,7 @@
       </p:sp>
       <p:pic>
         <p:nvPicPr>
-          <p:cNvPr id="5" name="Picture 4" descr="image.png"/>
+          <p:cNvPr id="6" name="Picture 5" descr="image.png"/>
           <p:cNvPicPr>
             <a:picLocks noChangeAspect="1"/>
           </p:cNvPicPr>
@@ -5378,8 +5360,8 @@
         </p:blipFill>
         <p:spPr>
           <a:xfrm>
-            <a:off x="9376767" y="561975"/>
-            <a:ext cx="2205632" cy="381000"/>
+            <a:off x="923925" y="2652712"/>
+            <a:ext cx="381000" cy="381000"/>
           </a:xfrm>
           <a:prstGeom prst="rect">
             <a:avLst/>
@@ -5388,7 +5370,31 @@
       </p:pic>
       <p:pic>
         <p:nvPicPr>
-          <p:cNvPr id="6" name="Picture 5" descr="image.png"/>
+          <p:cNvPr id="7" name="Picture 6" descr="image.png"/>
+          <p:cNvPicPr>
+            <a:picLocks noChangeAspect="1"/>
+          </p:cNvPicPr>
+          <p:nvPr/>
+        </p:nvPicPr>
+        <p:blipFill>
+          <a:blip r:embed="rId2"/>
+          <a:stretch>
+            <a:fillRect/>
+          </a:stretch>
+        </p:blipFill>
+        <p:spPr>
+          <a:xfrm>
+            <a:off x="6562725" y="2652712"/>
+            <a:ext cx="381000" cy="381000"/>
+          </a:xfrm>
+          <a:prstGeom prst="rect">
+            <a:avLst/>
+          </a:prstGeom>
+        </p:spPr>
+      </p:pic>
+      <p:pic>
+        <p:nvPicPr>
+          <p:cNvPr id="8" name="Picture 7" descr="image.png"/>
           <p:cNvPicPr>
             <a:picLocks noChangeAspect="1"/>
           </p:cNvPicPr>
@@ -5402,8 +5408,8 @@
         </p:blipFill>
         <p:spPr>
           <a:xfrm>
-            <a:off x="923925" y="2652712"/>
-            <a:ext cx="381000" cy="381000"/>
+            <a:off x="1019175" y="2747962"/>
+            <a:ext cx="190500" cy="190500"/>
           </a:xfrm>
           <a:prstGeom prst="rect">
             <a:avLst/>
@@ -5412,31 +5418,7 @@
       </p:pic>
       <p:pic>
         <p:nvPicPr>
-          <p:cNvPr id="7" name="Picture 6" descr="image.png"/>
-          <p:cNvPicPr>
-            <a:picLocks noChangeAspect="1"/>
-          </p:cNvPicPr>
-          <p:nvPr/>
-        </p:nvPicPr>
-        <p:blipFill>
-          <a:blip r:embed="rId3"/>
-          <a:stretch>
-            <a:fillRect/>
-          </a:stretch>
-        </p:blipFill>
-        <p:spPr>
-          <a:xfrm>
-            <a:off x="6562725" y="2652712"/>
-            <a:ext cx="381000" cy="381000"/>
-          </a:xfrm>
-          <a:prstGeom prst="rect">
-            <a:avLst/>
-          </a:prstGeom>
-        </p:spPr>
-      </p:pic>
-      <p:pic>
-        <p:nvPicPr>
-          <p:cNvPr id="8" name="Picture 7" descr="image.png"/>
+          <p:cNvPr id="9" name="Picture 8" descr="image.png"/>
           <p:cNvPicPr>
             <a:picLocks noChangeAspect="1"/>
           </p:cNvPicPr>
@@ -5450,7 +5432,7 @@
         </p:blipFill>
         <p:spPr>
           <a:xfrm>
-            <a:off x="1019175" y="2747962"/>
+            <a:off x="6657975" y="2747962"/>
             <a:ext cx="190500" cy="190500"/>
           </a:xfrm>
           <a:prstGeom prst="rect">
@@ -5458,9 +5440,303 @@
           </a:prstGeom>
         </p:spPr>
       </p:pic>
+      <p:sp>
+        <p:nvSpPr>
+          <p:cNvPr id="10" name="TextBox 9"/>
+          <p:cNvSpPr txBox="1"/>
+          <p:nvPr/>
+        </p:nvSpPr>
+        <p:spPr>
+          <a:xfrm>
+            <a:off x="876300" y="6010275"/>
+            <a:ext cx="1785937" cy="200025"/>
+          </a:xfrm>
+          <a:prstGeom prst="rect">
+            <a:avLst/>
+          </a:prstGeom>
+          <a:noFill/>
+        </p:spPr>
+        <p:txBody>
+          <a:bodyPr wrap="none" lIns="0" tIns="0" rIns="0" bIns="0" anchor="t">
+            <a:spAutoFit/>
+          </a:bodyPr>
+          <a:lstStyle/>
+          <a:p>
+            <a:pPr algn="l"/>
+            <a:r>
+              <a:rPr sz="1200" b="1" i="0" u="none">
+                <a:solidFill>
+                  <a:srgbClr val="38BDF8"/>
+                </a:solidFill>
+                <a:latin typeface="Plus Jakarta Sans"/>
+              </a:rPr>
+              <a:t>Livrable Semaine 1 :</a:t>
+            </a:r>
+          </a:p>
+        </p:txBody>
+      </p:sp>
+      <p:sp>
+        <p:nvSpPr>
+          <p:cNvPr id="11" name="TextBox 10"/>
+          <p:cNvSpPr txBox="1"/>
+          <p:nvPr/>
+        </p:nvSpPr>
+        <p:spPr>
+          <a:xfrm>
+            <a:off x="4867275" y="6010275"/>
+            <a:ext cx="7324725" cy="200025"/>
+          </a:xfrm>
+          <a:prstGeom prst="rect">
+            <a:avLst/>
+          </a:prstGeom>
+          <a:noFill/>
+        </p:spPr>
+        <p:txBody>
+          <a:bodyPr wrap="none" lIns="0" tIns="0" rIns="0" bIns="0" anchor="t">
+            <a:spAutoFit/>
+          </a:bodyPr>
+          <a:lstStyle/>
+          <a:p>
+            <a:pPr algn="l"/>
+            <a:r>
+              <a:rPr sz="1200" b="0" i="0" u="none">
+                <a:solidFill>
+                  <a:srgbClr val="F8FAFC"/>
+                </a:solidFill>
+                <a:latin typeface="Plus Jakarta Sans"/>
+              </a:rPr>
+              <a:t>Cadrage business, profilage de données, questions analytiques, tableau KPI et wireframe.</a:t>
+            </a:r>
+          </a:p>
+        </p:txBody>
+      </p:sp>
+      <p:sp>
+        <p:nvSpPr>
+          <p:cNvPr id="12" name="TextBox 11"/>
+          <p:cNvSpPr txBox="1"/>
+          <p:nvPr/>
+        </p:nvSpPr>
+        <p:spPr>
+          <a:xfrm>
+            <a:off x="609600" y="457200"/>
+            <a:ext cx="7060406" cy="171450"/>
+          </a:xfrm>
+          <a:prstGeom prst="rect">
+            <a:avLst/>
+          </a:prstGeom>
+          <a:noFill/>
+        </p:spPr>
+        <p:txBody>
+          <a:bodyPr wrap="none" lIns="0" tIns="0" rIns="0" bIns="0" anchor="t">
+            <a:spAutoFit/>
+          </a:bodyPr>
+          <a:lstStyle/>
+          <a:p>
+            <a:pPr algn="l"/>
+            <a:r>
+              <a:rPr sz="1050" b="1" i="0" u="none">
+                <a:solidFill>
+                  <a:srgbClr val="0284C7"/>
+                </a:solidFill>
+                <a:latin typeface="Plus Jakarta Sans"/>
+              </a:rPr>
+              <a:t>01. CONTEXTE STRATEGIQUE</a:t>
+            </a:r>
+          </a:p>
+        </p:txBody>
+      </p:sp>
+      <p:sp>
+        <p:nvSpPr>
+          <p:cNvPr id="13" name="TextBox 12"/>
+          <p:cNvSpPr txBox="1"/>
+          <p:nvPr/>
+        </p:nvSpPr>
+        <p:spPr>
+          <a:xfrm>
+            <a:off x="609600" y="666750"/>
+            <a:ext cx="7413426" cy="381000"/>
+          </a:xfrm>
+          <a:prstGeom prst="rect">
+            <a:avLst/>
+          </a:prstGeom>
+          <a:noFill/>
+        </p:spPr>
+        <p:txBody>
+          <a:bodyPr wrap="none" lIns="0" tIns="0" rIns="0" bIns="0" anchor="t">
+            <a:spAutoFit/>
+          </a:bodyPr>
+          <a:lstStyle/>
+          <a:p>
+            <a:pPr algn="l"/>
+            <a:r>
+              <a:rPr sz="2400" b="1" i="0" u="none">
+                <a:solidFill>
+                  <a:srgbClr val="0F172A"/>
+                </a:solidFill>
+                <a:latin typeface="Plus Jakarta Sans"/>
+              </a:rPr>
+              <a:t>Problématique &amp; Rôle du Data Analyst</a:t>
+            </a:r>
+          </a:p>
+        </p:txBody>
+      </p:sp>
+      <p:sp>
+        <p:nvSpPr>
+          <p:cNvPr id="14" name="TextBox 13"/>
+          <p:cNvSpPr txBox="1"/>
+          <p:nvPr/>
+        </p:nvSpPr>
+        <p:spPr>
+          <a:xfrm>
+            <a:off x="923925" y="3186112"/>
+            <a:ext cx="4800600" cy="1028700"/>
+          </a:xfrm>
+          <a:prstGeom prst="rect">
+            <a:avLst/>
+          </a:prstGeom>
+          <a:noFill/>
+        </p:spPr>
+        <p:txBody>
+          <a:bodyPr wrap="square" lIns="0" tIns="0" rIns="0" bIns="0" anchor="t">
+            <a:spAutoFit/>
+          </a:bodyPr>
+          <a:lstStyle/>
+          <a:p>
+            <a:pPr algn="l">
+              <a:lnSpc>
+                <a:spcPts val="2025"/>
+              </a:lnSpc>
+            </a:pPr>
+            <a:r>
+              <a:rPr sz="1350" b="0" i="0" u="none">
+                <a:solidFill>
+                  <a:srgbClr val="334155"/>
+                </a:solidFill>
+                <a:latin typeface="Plus Jakarta Sans"/>
+              </a:rPr>
+              <a:t>Banque 100% digitale au Nigéria (devise NGN) cherchant à exploiter ses données clients et transactions pour optimiser l'engagement, sécuriser les opérations et réduire les échecs réseau.</a:t>
+            </a:r>
+          </a:p>
+        </p:txBody>
+      </p:sp>
+      <p:sp>
+        <p:nvSpPr>
+          <p:cNvPr id="15" name="TextBox 14"/>
+          <p:cNvSpPr txBox="1"/>
+          <p:nvPr/>
+        </p:nvSpPr>
+        <p:spPr>
+          <a:xfrm>
+            <a:off x="6562725" y="3186112"/>
+            <a:ext cx="4800600" cy="1028700"/>
+          </a:xfrm>
+          <a:prstGeom prst="rect">
+            <a:avLst/>
+          </a:prstGeom>
+          <a:noFill/>
+        </p:spPr>
+        <p:txBody>
+          <a:bodyPr wrap="square" lIns="0" tIns="0" rIns="0" bIns="0" anchor="t">
+            <a:spAutoFit/>
+          </a:bodyPr>
+          <a:lstStyle/>
+          <a:p>
+            <a:pPr algn="l">
+              <a:lnSpc>
+                <a:spcPts val="2025"/>
+              </a:lnSpc>
+            </a:pPr>
+            <a:r>
+              <a:rPr sz="1350" b="0" i="0" u="none">
+                <a:solidFill>
+                  <a:srgbClr val="334155"/>
+                </a:solidFill>
+                <a:latin typeface="Plus Jakarta Sans"/>
+              </a:rPr>
+              <a:t>Transformer la masse de données brutes en intelligence décisionnelle exploitable via du profilage, des tableaux de définition KPI et la conception d'un dashboard interactif Power BI.</a:t>
+            </a:r>
+          </a:p>
+        </p:txBody>
+      </p:sp>
+      <p:sp>
+        <p:nvSpPr>
+          <p:cNvPr id="16" name="TextBox 15"/>
+          <p:cNvSpPr txBox="1"/>
+          <p:nvPr/>
+        </p:nvSpPr>
+        <p:spPr>
+          <a:xfrm>
+            <a:off x="1419225" y="2724150"/>
+            <a:ext cx="3312914" cy="238125"/>
+          </a:xfrm>
+          <a:prstGeom prst="rect">
+            <a:avLst/>
+          </a:prstGeom>
+          <a:noFill/>
+        </p:spPr>
+        <p:txBody>
+          <a:bodyPr wrap="none" lIns="0" tIns="0" rIns="0" bIns="0" anchor="t">
+            <a:spAutoFit/>
+          </a:bodyPr>
+          <a:lstStyle/>
+          <a:p>
+            <a:pPr algn="l"/>
+            <a:r>
+              <a:rPr sz="1500" b="1" i="0" u="none">
+                <a:solidFill>
+                  <a:srgbClr val="0F172A"/>
+                </a:solidFill>
+                <a:latin typeface="Plus Jakarta Sans"/>
+              </a:rPr>
+              <a:t>Enjeux FinTrust Digital Bank</a:t>
+            </a:r>
+          </a:p>
+        </p:txBody>
+      </p:sp>
+      <p:sp>
+        <p:nvSpPr>
+          <p:cNvPr id="17" name="TextBox 16"/>
+          <p:cNvSpPr txBox="1"/>
+          <p:nvPr/>
+        </p:nvSpPr>
+        <p:spPr>
+          <a:xfrm>
+            <a:off x="7058025" y="2724150"/>
+            <a:ext cx="2875359" cy="238125"/>
+          </a:xfrm>
+          <a:prstGeom prst="rect">
+            <a:avLst/>
+          </a:prstGeom>
+          <a:noFill/>
+        </p:spPr>
+        <p:txBody>
+          <a:bodyPr wrap="none" lIns="0" tIns="0" rIns="0" bIns="0" anchor="t">
+            <a:spAutoFit/>
+          </a:bodyPr>
+          <a:lstStyle/>
+          <a:p>
+            <a:pPr algn="l"/>
+            <a:r>
+              <a:rPr sz="1500" b="1" i="0" u="none">
+                <a:solidFill>
+                  <a:srgbClr val="0F172A"/>
+                </a:solidFill>
+                <a:latin typeface="Plus Jakarta Sans"/>
+              </a:rPr>
+              <a:t>Mission du Data Analyst</a:t>
+            </a:r>
+          </a:p>
+        </p:txBody>
+      </p:sp>
       <p:pic>
         <p:nvPicPr>
-          <p:cNvPr id="9" name="Picture 8" descr="image.png"/>
+          <p:cNvPr id="23" name="Image 22" descr="Photo de profil de analystlabafrica">
+            <a:extLst>
+              <a:ext uri="{FF2B5EF4-FFF2-40B4-BE49-F238E27FC236}">
+                <a16:creationId xmlns:a16="http://schemas.microsoft.com/office/drawing/2014/main" id="{6DCAC895-E61E-F5D5-0E89-EF3AAC11A65C}"/>
+              </a:ext>
+            </a:extLst>
+          </p:cNvPr>
           <p:cNvPicPr>
             <a:picLocks noChangeAspect="1"/>
           </p:cNvPicPr>
@@ -5474,302 +5750,14 @@
         </p:blipFill>
         <p:spPr>
           <a:xfrm>
-            <a:off x="6657975" y="2747962"/>
-            <a:ext cx="190500" cy="190500"/>
+            <a:off x="11167651" y="31941"/>
+            <a:ext cx="1024349" cy="1024349"/>
           </a:xfrm>
           <a:prstGeom prst="rect">
             <a:avLst/>
           </a:prstGeom>
         </p:spPr>
       </p:pic>
-      <p:sp>
-        <p:nvSpPr>
-          <p:cNvPr id="10" name="TextBox 9"/>
-          <p:cNvSpPr txBox="1"/>
-          <p:nvPr/>
-        </p:nvSpPr>
-        <p:spPr>
-          <a:xfrm>
-            <a:off x="876300" y="6010275"/>
-            <a:ext cx="1785937" cy="200025"/>
-          </a:xfrm>
-          <a:prstGeom prst="rect">
-            <a:avLst/>
-          </a:prstGeom>
-          <a:noFill/>
-        </p:spPr>
-        <p:txBody>
-          <a:bodyPr wrap="none" lIns="0" tIns="0" rIns="0" bIns="0" anchor="t">
-            <a:spAutoFit/>
-          </a:bodyPr>
-          <a:lstStyle/>
-          <a:p>
-            <a:pPr algn="l"/>
-            <a:r>
-              <a:rPr sz="1200" b="1" i="0" u="none">
-                <a:solidFill>
-                  <a:srgbClr val="38BDF8"/>
-                </a:solidFill>
-                <a:latin typeface="Plus Jakarta Sans"/>
-              </a:rPr>
-              <a:t>Livrable Semaine 1 :</a:t>
-            </a:r>
-          </a:p>
-        </p:txBody>
-      </p:sp>
-      <p:sp>
-        <p:nvSpPr>
-          <p:cNvPr id="11" name="TextBox 10"/>
-          <p:cNvSpPr txBox="1"/>
-          <p:nvPr/>
-        </p:nvSpPr>
-        <p:spPr>
-          <a:xfrm>
-            <a:off x="4867275" y="6010275"/>
-            <a:ext cx="7324725" cy="200025"/>
-          </a:xfrm>
-          <a:prstGeom prst="rect">
-            <a:avLst/>
-          </a:prstGeom>
-          <a:noFill/>
-        </p:spPr>
-        <p:txBody>
-          <a:bodyPr wrap="none" lIns="0" tIns="0" rIns="0" bIns="0" anchor="t">
-            <a:spAutoFit/>
-          </a:bodyPr>
-          <a:lstStyle/>
-          <a:p>
-            <a:pPr algn="l"/>
-            <a:r>
-              <a:rPr sz="1200" b="0" i="0" u="none">
-                <a:solidFill>
-                  <a:srgbClr val="F8FAFC"/>
-                </a:solidFill>
-                <a:latin typeface="Plus Jakarta Sans"/>
-              </a:rPr>
-              <a:t>Cadrage business, profilage de données, questions analytiques, tableau KPI et wireframe.</a:t>
-            </a:r>
-          </a:p>
-        </p:txBody>
-      </p:sp>
-      <p:sp>
-        <p:nvSpPr>
-          <p:cNvPr id="12" name="TextBox 11"/>
-          <p:cNvSpPr txBox="1"/>
-          <p:nvPr/>
-        </p:nvSpPr>
-        <p:spPr>
-          <a:xfrm>
-            <a:off x="609600" y="457200"/>
-            <a:ext cx="7060406" cy="171450"/>
-          </a:xfrm>
-          <a:prstGeom prst="rect">
-            <a:avLst/>
-          </a:prstGeom>
-          <a:noFill/>
-        </p:spPr>
-        <p:txBody>
-          <a:bodyPr wrap="none" lIns="0" tIns="0" rIns="0" bIns="0" anchor="t">
-            <a:spAutoFit/>
-          </a:bodyPr>
-          <a:lstStyle/>
-          <a:p>
-            <a:pPr algn="l"/>
-            <a:r>
-              <a:rPr sz="1050" b="1" i="0" u="none">
-                <a:solidFill>
-                  <a:srgbClr val="0284C7"/>
-                </a:solidFill>
-                <a:latin typeface="Plus Jakarta Sans"/>
-              </a:rPr>
-              <a:t>01. CONTEXTE STRATEGIQUE</a:t>
-            </a:r>
-          </a:p>
-        </p:txBody>
-      </p:sp>
-      <p:sp>
-        <p:nvSpPr>
-          <p:cNvPr id="13" name="TextBox 12"/>
-          <p:cNvSpPr txBox="1"/>
-          <p:nvPr/>
-        </p:nvSpPr>
-        <p:spPr>
-          <a:xfrm>
-            <a:off x="609600" y="666750"/>
-            <a:ext cx="7413426" cy="381000"/>
-          </a:xfrm>
-          <a:prstGeom prst="rect">
-            <a:avLst/>
-          </a:prstGeom>
-          <a:noFill/>
-        </p:spPr>
-        <p:txBody>
-          <a:bodyPr wrap="none" lIns="0" tIns="0" rIns="0" bIns="0" anchor="t">
-            <a:spAutoFit/>
-          </a:bodyPr>
-          <a:lstStyle/>
-          <a:p>
-            <a:pPr algn="l"/>
-            <a:r>
-              <a:rPr sz="2400" b="1" i="0" u="none">
-                <a:solidFill>
-                  <a:srgbClr val="0F172A"/>
-                </a:solidFill>
-                <a:latin typeface="Plus Jakarta Sans"/>
-              </a:rPr>
-              <a:t>Problématique &amp; Rôle du Data Analyst</a:t>
-            </a:r>
-          </a:p>
-        </p:txBody>
-      </p:sp>
-      <p:sp>
-        <p:nvSpPr>
-          <p:cNvPr id="14" name="TextBox 13"/>
-          <p:cNvSpPr txBox="1"/>
-          <p:nvPr/>
-        </p:nvSpPr>
-        <p:spPr>
-          <a:xfrm>
-            <a:off x="923925" y="3186112"/>
-            <a:ext cx="4800600" cy="1028700"/>
-          </a:xfrm>
-          <a:prstGeom prst="rect">
-            <a:avLst/>
-          </a:prstGeom>
-          <a:noFill/>
-        </p:spPr>
-        <p:txBody>
-          <a:bodyPr wrap="square" lIns="0" tIns="0" rIns="0" bIns="0" anchor="t">
-            <a:spAutoFit/>
-          </a:bodyPr>
-          <a:lstStyle/>
-          <a:p>
-            <a:pPr algn="l">
-              <a:lnSpc>
-                <a:spcPts val="2025"/>
-              </a:lnSpc>
-            </a:pPr>
-            <a:r>
-              <a:rPr sz="1350" b="0" i="0" u="none">
-                <a:solidFill>
-                  <a:srgbClr val="334155"/>
-                </a:solidFill>
-                <a:latin typeface="Plus Jakarta Sans"/>
-              </a:rPr>
-              <a:t>Banque 100% digitale au Nigéria (devise NGN) cherchant à exploiter ses données clients et transactions pour optimiser l'engagement, sécuriser les opérations et réduire les échecs réseau.</a:t>
-            </a:r>
-          </a:p>
-        </p:txBody>
-      </p:sp>
-      <p:sp>
-        <p:nvSpPr>
-          <p:cNvPr id="15" name="TextBox 14"/>
-          <p:cNvSpPr txBox="1"/>
-          <p:nvPr/>
-        </p:nvSpPr>
-        <p:spPr>
-          <a:xfrm>
-            <a:off x="6562725" y="3186112"/>
-            <a:ext cx="4800600" cy="1028700"/>
-          </a:xfrm>
-          <a:prstGeom prst="rect">
-            <a:avLst/>
-          </a:prstGeom>
-          <a:noFill/>
-        </p:spPr>
-        <p:txBody>
-          <a:bodyPr wrap="square" lIns="0" tIns="0" rIns="0" bIns="0" anchor="t">
-            <a:spAutoFit/>
-          </a:bodyPr>
-          <a:lstStyle/>
-          <a:p>
-            <a:pPr algn="l">
-              <a:lnSpc>
-                <a:spcPts val="2025"/>
-              </a:lnSpc>
-            </a:pPr>
-            <a:r>
-              <a:rPr sz="1350" b="0" i="0" u="none">
-                <a:solidFill>
-                  <a:srgbClr val="334155"/>
-                </a:solidFill>
-                <a:latin typeface="Plus Jakarta Sans"/>
-              </a:rPr>
-              <a:t>Transformer la masse de données brutes en intelligence décisionnelle exploitable via du profilage, des tableaux de définition KPI et la conception d'un dashboard interactif Power BI.</a:t>
-            </a:r>
-          </a:p>
-        </p:txBody>
-      </p:sp>
-      <p:sp>
-        <p:nvSpPr>
-          <p:cNvPr id="16" name="TextBox 15"/>
-          <p:cNvSpPr txBox="1"/>
-          <p:nvPr/>
-        </p:nvSpPr>
-        <p:spPr>
-          <a:xfrm>
-            <a:off x="1419225" y="2724150"/>
-            <a:ext cx="3312914" cy="238125"/>
-          </a:xfrm>
-          <a:prstGeom prst="rect">
-            <a:avLst/>
-          </a:prstGeom>
-          <a:noFill/>
-        </p:spPr>
-        <p:txBody>
-          <a:bodyPr wrap="none" lIns="0" tIns="0" rIns="0" bIns="0" anchor="t">
-            <a:spAutoFit/>
-          </a:bodyPr>
-          <a:lstStyle/>
-          <a:p>
-            <a:pPr algn="l"/>
-            <a:r>
-              <a:rPr sz="1500" b="1" i="0" u="none">
-                <a:solidFill>
-                  <a:srgbClr val="0F172A"/>
-                </a:solidFill>
-                <a:latin typeface="Plus Jakarta Sans"/>
-              </a:rPr>
-              <a:t>Enjeux FinTrust Digital Bank</a:t>
-            </a:r>
-          </a:p>
-        </p:txBody>
-      </p:sp>
-      <p:sp>
-        <p:nvSpPr>
-          <p:cNvPr id="17" name="TextBox 16"/>
-          <p:cNvSpPr txBox="1"/>
-          <p:nvPr/>
-        </p:nvSpPr>
-        <p:spPr>
-          <a:xfrm>
-            <a:off x="7058025" y="2724150"/>
-            <a:ext cx="2875359" cy="238125"/>
-          </a:xfrm>
-          <a:prstGeom prst="rect">
-            <a:avLst/>
-          </a:prstGeom>
-          <a:noFill/>
-        </p:spPr>
-        <p:txBody>
-          <a:bodyPr wrap="none" lIns="0" tIns="0" rIns="0" bIns="0" anchor="t">
-            <a:spAutoFit/>
-          </a:bodyPr>
-          <a:lstStyle/>
-          <a:p>
-            <a:pPr algn="l"/>
-            <a:r>
-              <a:rPr sz="1500" b="1" i="0" u="none">
-                <a:solidFill>
-                  <a:srgbClr val="0F172A"/>
-                </a:solidFill>
-                <a:latin typeface="Plus Jakarta Sans"/>
-              </a:rPr>
-              <a:t>Mission du Data Analyst</a:t>
-            </a:r>
-          </a:p>
-        </p:txBody>
-      </p:sp>
     </p:spTree>
   </p:cSld>
   <p:clrMapOvr>

</xml_diff>